<commit_message>
indicator cleanup to only those used
</commit_message>
<xml_diff>
--- a/pci_poster/poster_template.pptx
+++ b/pci_poster/poster_template.pptx
@@ -250,19 +250,19 @@
   </pc:docChgLst>
   <pc:docChgLst>
     <pc:chgData name="Gillett, Richard" userId="f751afb3-89ee-4adb-bf46-b352b62550b4" providerId="ADAL" clId="{4E0FD693-728A-4417-BDB5-6E29955B45D4}"/>
-    <pc:docChg chg="modMainMaster">
-      <pc:chgData name="Gillett, Richard" userId="f751afb3-89ee-4adb-bf46-b352b62550b4" providerId="ADAL" clId="{4E0FD693-728A-4417-BDB5-6E29955B45D4}" dt="2026-06-10T05:52:21.966" v="1" actId="20577"/>
+    <pc:docChg chg="custSel modMainMaster">
+      <pc:chgData name="Gillett, Richard" userId="f751afb3-89ee-4adb-bf46-b352b62550b4" providerId="ADAL" clId="{4E0FD693-728A-4417-BDB5-6E29955B45D4}" dt="2026-06-10T08:00:51.893" v="2" actId="478"/>
       <pc:docMkLst>
         <pc:docMk/>
       </pc:docMkLst>
       <pc:sldMasterChg chg="modSldLayout">
-        <pc:chgData name="Gillett, Richard" userId="f751afb3-89ee-4adb-bf46-b352b62550b4" providerId="ADAL" clId="{4E0FD693-728A-4417-BDB5-6E29955B45D4}" dt="2026-06-10T05:52:21.966" v="1" actId="20577"/>
+        <pc:chgData name="Gillett, Richard" userId="f751afb3-89ee-4adb-bf46-b352b62550b4" providerId="ADAL" clId="{4E0FD693-728A-4417-BDB5-6E29955B45D4}" dt="2026-06-10T08:00:51.893" v="2" actId="478"/>
         <pc:sldMasterMkLst>
           <pc:docMk/>
           <pc:sldMasterMk cId="2640799190" sldId="2147483660"/>
         </pc:sldMasterMkLst>
-        <pc:sldLayoutChg chg="modSp mod">
-          <pc:chgData name="Gillett, Richard" userId="f751afb3-89ee-4adb-bf46-b352b62550b4" providerId="ADAL" clId="{4E0FD693-728A-4417-BDB5-6E29955B45D4}" dt="2026-06-10T05:52:21.966" v="1" actId="20577"/>
+        <pc:sldLayoutChg chg="delSp modSp mod">
+          <pc:chgData name="Gillett, Richard" userId="f751afb3-89ee-4adb-bf46-b352b62550b4" providerId="ADAL" clId="{4E0FD693-728A-4417-BDB5-6E29955B45D4}" dt="2026-06-10T08:00:51.893" v="2" actId="478"/>
           <pc:sldLayoutMkLst>
             <pc:docMk/>
             <pc:sldMasterMk cId="2640799190" sldId="2147483660"/>
@@ -277,6 +277,15 @@
               <ac:spMk id="43" creationId="{CDBAF79C-1ECD-4077-B693-FAA616F38BB3}"/>
             </ac:spMkLst>
           </pc:spChg>
+          <pc:cxnChg chg="del">
+            <ac:chgData name="Gillett, Richard" userId="f751afb3-89ee-4adb-bf46-b352b62550b4" providerId="ADAL" clId="{4E0FD693-728A-4417-BDB5-6E29955B45D4}" dt="2026-06-10T08:00:51.893" v="2" actId="478"/>
+            <ac:cxnSpMkLst>
+              <pc:docMk/>
+              <pc:sldMasterMk cId="2640799190" sldId="2147483660"/>
+              <pc:sldLayoutMk cId="1363397331" sldId="2147483661"/>
+              <ac:cxnSpMk id="4" creationId="{5BB082F5-DE58-9BB3-E67C-CBAE81B32259}"/>
+            </ac:cxnSpMkLst>
+          </pc:cxnChg>
         </pc:sldLayoutChg>
       </pc:sldMasterChg>
     </pc:docChg>
@@ -667,51 +676,6 @@
           </a:prstGeom>
         </p:spPr>
       </p:pic>
-      <p:cxnSp>
-        <p:nvCxnSpPr>
-          <p:cNvPr id="4" name="steth_stem">
-            <a:extLst>
-              <a:ext uri="{FF2B5EF4-FFF2-40B4-BE49-F238E27FC236}">
-                <a16:creationId xmlns:a16="http://schemas.microsoft.com/office/drawing/2014/main" id="{5BB082F5-DE58-9BB3-E67C-CBAE81B32259}"/>
-              </a:ext>
-            </a:extLst>
-          </p:cNvPr>
-          <p:cNvCxnSpPr>
-            <a:cxnSpLocks/>
-          </p:cNvCxnSpPr>
-          <p:nvPr userDrawn="1"/>
-        </p:nvCxnSpPr>
-        <p:spPr>
-          <a:xfrm>
-            <a:off x="65965" y="8691366"/>
-            <a:ext cx="1852" cy="330402"/>
-          </a:xfrm>
-          <a:prstGeom prst="line">
-            <a:avLst/>
-          </a:prstGeom>
-          <a:ln w="76200">
-            <a:solidFill>
-              <a:schemeClr val="bg1">
-                <a:lumMod val="65000"/>
-              </a:schemeClr>
-            </a:solidFill>
-          </a:ln>
-        </p:spPr>
-        <p:style>
-          <a:lnRef idx="1">
-            <a:schemeClr val="accent1"/>
-          </a:lnRef>
-          <a:fillRef idx="0">
-            <a:schemeClr val="accent1"/>
-          </a:fillRef>
-          <a:effectRef idx="0">
-            <a:schemeClr val="accent1"/>
-          </a:effectRef>
-          <a:fontRef idx="minor">
-            <a:schemeClr val="tx1"/>
-          </a:fontRef>
-        </p:style>
-      </p:cxnSp>
       <p:sp>
         <p:nvSpPr>
           <p:cNvPr id="15" name="shp_circle_yellow">

</xml_diff>

<commit_message>
Remove image stating that sample data is used
</commit_message>
<xml_diff>
--- a/pci_poster/poster_template.pptx
+++ b/pci_poster/poster_template.pptx
@@ -114,6 +114,30 @@
 
 <file path=ppt/changesInfos/changesInfo1.xml><?xml version="1.0" encoding="utf-8"?>
 <pc:chgInfo xmlns:a="http://schemas.openxmlformats.org/drawingml/2006/main" xmlns:r="http://schemas.openxmlformats.org/officeDocument/2006/relationships" xmlns:ac="http://schemas.microsoft.com/office/drawing/2013/main/command" xmlns:pc="http://schemas.microsoft.com/office/powerpoint/2013/main/command">
+  <pc:docChgLst>
+    <pc:chgData name="Gillett, Richard" userId="f751afb3-89ee-4adb-bf46-b352b62550b4" providerId="ADAL" clId="{947C8103-4DC6-4827-8B43-5C2E904880F7}"/>
+    <pc:docChg chg="undo custSel modMainMaster">
+      <pc:chgData name="Gillett, Richard" userId="f751afb3-89ee-4adb-bf46-b352b62550b4" providerId="ADAL" clId="{947C8103-4DC6-4827-8B43-5C2E904880F7}" dt="2026-01-06T08:14:35.035" v="119" actId="1035"/>
+      <pc:docMkLst>
+        <pc:docMk/>
+      </pc:docMkLst>
+      <pc:sldMasterChg chg="modSp mod modSldLayout">
+        <pc:chgData name="Gillett, Richard" userId="f751afb3-89ee-4adb-bf46-b352b62550b4" providerId="ADAL" clId="{947C8103-4DC6-4827-8B43-5C2E904880F7}" dt="2026-01-06T08:14:35.035" v="119" actId="1035"/>
+        <pc:sldMasterMkLst>
+          <pc:docMk/>
+          <pc:sldMasterMk cId="2640799190" sldId="2147483660"/>
+        </pc:sldMasterMkLst>
+        <pc:sldLayoutChg chg="modSp mod">
+          <pc:chgData name="Gillett, Richard" userId="f751afb3-89ee-4adb-bf46-b352b62550b4" providerId="ADAL" clId="{947C8103-4DC6-4827-8B43-5C2E904880F7}" dt="2026-01-06T08:14:35.035" v="119" actId="1035"/>
+          <pc:sldLayoutMkLst>
+            <pc:docMk/>
+            <pc:sldMasterMk cId="2640799190" sldId="2147483660"/>
+            <pc:sldLayoutMk cId="1363397331" sldId="2147483661"/>
+          </pc:sldLayoutMkLst>
+        </pc:sldLayoutChg>
+      </pc:sldMasterChg>
+    </pc:docChg>
+  </pc:docChgLst>
   <pc:docChgLst>
     <pc:chgData name="Gillett, Richard" userId="f751afb3-89ee-4adb-bf46-b352b62550b4" providerId="ADAL" clId="{E1DC7D8A-5337-4AAE-9935-D0A80B248513}"/>
     <pc:docChg chg="undo redo custSel modSld addMainMaster delMainMaster modMainMaster">
@@ -249,6 +273,37 @@
     </pc:docChg>
   </pc:docChgLst>
   <pc:docChgLst>
+    <pc:chgData name="Gillett, Richard" userId="f751afb3-89ee-4adb-bf46-b352b62550b4" providerId="ADAL" clId="{A5BB3A64-C60C-45E9-BAE7-11B96E1E2D18}"/>
+    <pc:docChg chg="undo custSel modSld modMainMaster">
+      <pc:chgData name="Gillett, Richard" userId="f751afb3-89ee-4adb-bf46-b352b62550b4" providerId="ADAL" clId="{A5BB3A64-C60C-45E9-BAE7-11B96E1E2D18}" dt="2026-02-05T07:26:13.627" v="547" actId="20577"/>
+      <pc:docMkLst>
+        <pc:docMk/>
+      </pc:docMkLst>
+      <pc:sldChg chg="modSp mod">
+        <pc:chgData name="Gillett, Richard" userId="f751afb3-89ee-4adb-bf46-b352b62550b4" providerId="ADAL" clId="{A5BB3A64-C60C-45E9-BAE7-11B96E1E2D18}" dt="2026-01-14T09:55:55.459" v="251" actId="14100"/>
+        <pc:sldMkLst>
+          <pc:docMk/>
+          <pc:sldMk cId="4050248657" sldId="258"/>
+        </pc:sldMkLst>
+      </pc:sldChg>
+      <pc:sldMasterChg chg="addSp delSp modSp mod modSldLayout">
+        <pc:chgData name="Gillett, Richard" userId="f751afb3-89ee-4adb-bf46-b352b62550b4" providerId="ADAL" clId="{A5BB3A64-C60C-45E9-BAE7-11B96E1E2D18}" dt="2026-02-05T07:26:13.627" v="547" actId="20577"/>
+        <pc:sldMasterMkLst>
+          <pc:docMk/>
+          <pc:sldMasterMk cId="2640799190" sldId="2147483660"/>
+        </pc:sldMasterMkLst>
+        <pc:sldLayoutChg chg="addSp delSp modSp mod">
+          <pc:chgData name="Gillett, Richard" userId="f751afb3-89ee-4adb-bf46-b352b62550b4" providerId="ADAL" clId="{A5BB3A64-C60C-45E9-BAE7-11B96E1E2D18}" dt="2026-01-20T23:56:46.184" v="545" actId="962"/>
+          <pc:sldLayoutMkLst>
+            <pc:docMk/>
+            <pc:sldMasterMk cId="2640799190" sldId="2147483660"/>
+            <pc:sldLayoutMk cId="1363397331" sldId="2147483661"/>
+          </pc:sldLayoutMkLst>
+        </pc:sldLayoutChg>
+      </pc:sldMasterChg>
+    </pc:docChg>
+  </pc:docChgLst>
+  <pc:docChgLst>
     <pc:chgData name="Gillett, Richard" userId="f751afb3-89ee-4adb-bf46-b352b62550b4" providerId="ADAL" clId="{4E0FD693-728A-4417-BDB5-6E29955B45D4}"/>
     <pc:docChg chg="custSel modMainMaster">
       <pc:chgData name="Gillett, Richard" userId="f751afb3-89ee-4adb-bf46-b352b62550b4" providerId="ADAL" clId="{4E0FD693-728A-4417-BDB5-6E29955B45D4}" dt="2026-06-10T08:00:51.893" v="2" actId="478"/>
@@ -291,30 +346,6 @@
     </pc:docChg>
   </pc:docChgLst>
   <pc:docChgLst>
-    <pc:chgData name="Gillett, Richard" userId="f751afb3-89ee-4adb-bf46-b352b62550b4" providerId="ADAL" clId="{947C8103-4DC6-4827-8B43-5C2E904880F7}"/>
-    <pc:docChg chg="undo custSel modMainMaster">
-      <pc:chgData name="Gillett, Richard" userId="f751afb3-89ee-4adb-bf46-b352b62550b4" providerId="ADAL" clId="{947C8103-4DC6-4827-8B43-5C2E904880F7}" dt="2026-01-06T08:14:35.035" v="119" actId="1035"/>
-      <pc:docMkLst>
-        <pc:docMk/>
-      </pc:docMkLst>
-      <pc:sldMasterChg chg="modSp mod modSldLayout">
-        <pc:chgData name="Gillett, Richard" userId="f751afb3-89ee-4adb-bf46-b352b62550b4" providerId="ADAL" clId="{947C8103-4DC6-4827-8B43-5C2E904880F7}" dt="2026-01-06T08:14:35.035" v="119" actId="1035"/>
-        <pc:sldMasterMkLst>
-          <pc:docMk/>
-          <pc:sldMasterMk cId="2640799190" sldId="2147483660"/>
-        </pc:sldMasterMkLst>
-        <pc:sldLayoutChg chg="modSp mod">
-          <pc:chgData name="Gillett, Richard" userId="f751afb3-89ee-4adb-bf46-b352b62550b4" providerId="ADAL" clId="{947C8103-4DC6-4827-8B43-5C2E904880F7}" dt="2026-01-06T08:14:35.035" v="119" actId="1035"/>
-          <pc:sldLayoutMkLst>
-            <pc:docMk/>
-            <pc:sldMasterMk cId="2640799190" sldId="2147483660"/>
-            <pc:sldLayoutMk cId="1363397331" sldId="2147483661"/>
-          </pc:sldLayoutMkLst>
-        </pc:sldLayoutChg>
-      </pc:sldMasterChg>
-    </pc:docChg>
-  </pc:docChgLst>
-  <pc:docChgLst>
     <pc:chgData name="Gillett, Richard" userId="f751afb3-89ee-4adb-bf46-b352b62550b4" providerId="ADAL" clId="{63D0502C-E45B-42C2-8995-A2AEF517A4FA}"/>
     <pc:docChg chg="undo custSel modMainMaster">
       <pc:chgData name="Gillett, Richard" userId="f751afb3-89ee-4adb-bf46-b352b62550b4" providerId="ADAL" clId="{63D0502C-E45B-42C2-8995-A2AEF517A4FA}" dt="2026-03-04T04:53:56.357" v="273" actId="962"/>
@@ -329,37 +360,6 @@
         </pc:sldMasterMkLst>
         <pc:sldLayoutChg chg="addSp delSp modSp mod">
           <pc:chgData name="Gillett, Richard" userId="f751afb3-89ee-4adb-bf46-b352b62550b4" providerId="ADAL" clId="{63D0502C-E45B-42C2-8995-A2AEF517A4FA}" dt="2026-03-04T04:53:56.357" v="273" actId="962"/>
-          <pc:sldLayoutMkLst>
-            <pc:docMk/>
-            <pc:sldMasterMk cId="2640799190" sldId="2147483660"/>
-            <pc:sldLayoutMk cId="1363397331" sldId="2147483661"/>
-          </pc:sldLayoutMkLst>
-        </pc:sldLayoutChg>
-      </pc:sldMasterChg>
-    </pc:docChg>
-  </pc:docChgLst>
-  <pc:docChgLst>
-    <pc:chgData name="Gillett, Richard" userId="f751afb3-89ee-4adb-bf46-b352b62550b4" providerId="ADAL" clId="{A5BB3A64-C60C-45E9-BAE7-11B96E1E2D18}"/>
-    <pc:docChg chg="undo custSel modSld modMainMaster">
-      <pc:chgData name="Gillett, Richard" userId="f751afb3-89ee-4adb-bf46-b352b62550b4" providerId="ADAL" clId="{A5BB3A64-C60C-45E9-BAE7-11B96E1E2D18}" dt="2026-02-05T07:26:13.627" v="547" actId="20577"/>
-      <pc:docMkLst>
-        <pc:docMk/>
-      </pc:docMkLst>
-      <pc:sldChg chg="modSp mod">
-        <pc:chgData name="Gillett, Richard" userId="f751afb3-89ee-4adb-bf46-b352b62550b4" providerId="ADAL" clId="{A5BB3A64-C60C-45E9-BAE7-11B96E1E2D18}" dt="2026-01-14T09:55:55.459" v="251" actId="14100"/>
-        <pc:sldMkLst>
-          <pc:docMk/>
-          <pc:sldMk cId="4050248657" sldId="258"/>
-        </pc:sldMkLst>
-      </pc:sldChg>
-      <pc:sldMasterChg chg="addSp delSp modSp mod modSldLayout">
-        <pc:chgData name="Gillett, Richard" userId="f751afb3-89ee-4adb-bf46-b352b62550b4" providerId="ADAL" clId="{A5BB3A64-C60C-45E9-BAE7-11B96E1E2D18}" dt="2026-02-05T07:26:13.627" v="547" actId="20577"/>
-        <pc:sldMasterMkLst>
-          <pc:docMk/>
-          <pc:sldMasterMk cId="2640799190" sldId="2147483660"/>
-        </pc:sldMasterMkLst>
-        <pc:sldLayoutChg chg="addSp delSp modSp mod">
-          <pc:chgData name="Gillett, Richard" userId="f751afb3-89ee-4adb-bf46-b352b62550b4" providerId="ADAL" clId="{A5BB3A64-C60C-45E9-BAE7-11B96E1E2D18}" dt="2026-01-20T23:56:46.184" v="545" actId="962"/>
           <pc:sldLayoutMkLst>
             <pc:docMk/>
             <pc:sldMasterMk cId="2640799190" sldId="2147483660"/>
@@ -2029,109 +2029,6 @@
           </a:p>
         </p:txBody>
       </p:sp>
-      <p:pic>
-        <p:nvPicPr>
-          <p:cNvPr id="3" name="sample" descr="A red stamp with text&#10;&#10;AI-generated content may be incorrect.">
-            <a:extLst>
-              <a:ext uri="{FF2B5EF4-FFF2-40B4-BE49-F238E27FC236}">
-                <a16:creationId xmlns:a16="http://schemas.microsoft.com/office/drawing/2014/main" id="{9498E89D-FFFB-BD02-CB4A-C6AF63419FA9}"/>
-              </a:ext>
-            </a:extLst>
-          </p:cNvPr>
-          <p:cNvPicPr>
-            <a:picLocks noChangeAspect="1"/>
-          </p:cNvPicPr>
-          <p:nvPr userDrawn="1"/>
-        </p:nvPicPr>
-        <p:blipFill>
-          <a:blip r:embed="rId9" cstate="screen">
-            <a:clrChange>
-              <a:clrFrom>
-                <a:srgbClr val="FFFFFF"/>
-              </a:clrFrom>
-              <a:clrTo>
-                <a:srgbClr val="FFFFFF">
-                  <a:alpha val="0"/>
-                </a:srgbClr>
-              </a:clrTo>
-            </a:clrChange>
-            <a:extLst>
-              <a:ext uri="{28A0092B-C50C-407E-A947-70E740481C1C}">
-                <a14:useLocalDpi xmlns:a14="http://schemas.microsoft.com/office/drawing/2010/main"/>
-              </a:ext>
-              <a:ext uri="{837473B0-CC2E-450A-ABE3-18F120FF3D39}">
-                <a1611:picAttrSrcUrl xmlns:a1611="http://schemas.microsoft.com/office/drawing/2016/11/main" r:id="rId10"/>
-              </a:ext>
-            </a:extLst>
-          </a:blip>
-          <a:srcRect/>
-          <a:stretch/>
-        </p:blipFill>
-        <p:spPr>
-          <a:xfrm>
-            <a:off x="2134689" y="1391252"/>
-            <a:ext cx="2464252" cy="1215059"/>
-          </a:xfrm>
-          <a:prstGeom prst="rect">
-            <a:avLst/>
-          </a:prstGeom>
-        </p:spPr>
-      </p:pic>
-      <p:sp>
-        <p:nvSpPr>
-          <p:cNvPr id="2" name="fake_data">
-            <a:extLst>
-              <a:ext uri="{FF2B5EF4-FFF2-40B4-BE49-F238E27FC236}">
-                <a16:creationId xmlns:a16="http://schemas.microsoft.com/office/drawing/2014/main" id="{4EA715C1-D099-5522-9B8D-6FE225FA3DB4}"/>
-              </a:ext>
-            </a:extLst>
-          </p:cNvPr>
-          <p:cNvSpPr/>
-          <p:nvPr userDrawn="1"/>
-        </p:nvSpPr>
-        <p:spPr>
-          <a:xfrm rot="20997267">
-            <a:off x="2782260" y="2371528"/>
-            <a:ext cx="1431931" cy="407786"/>
-          </a:xfrm>
-          <a:prstGeom prst="rect">
-            <a:avLst/>
-          </a:prstGeom>
-          <a:solidFill>
-            <a:srgbClr val="FF0000"/>
-          </a:solidFill>
-          <a:ln>
-            <a:noFill/>
-          </a:ln>
-        </p:spPr>
-        <p:style>
-          <a:lnRef idx="2">
-            <a:schemeClr val="accent1">
-              <a:shade val="15000"/>
-            </a:schemeClr>
-          </a:lnRef>
-          <a:fillRef idx="1">
-            <a:schemeClr val="accent1"/>
-          </a:fillRef>
-          <a:effectRef idx="0">
-            <a:schemeClr val="accent1"/>
-          </a:effectRef>
-          <a:fontRef idx="minor">
-            <a:schemeClr val="lt1"/>
-          </a:fontRef>
-        </p:style>
-        <p:txBody>
-          <a:bodyPr rtlCol="0" anchor="ctr"/>
-          <a:lstStyle/>
-          <a:p>
-            <a:pPr lvl="0" algn="ctr"/>
-            <a:r>
-              <a:rPr lang="en-AU" sz="1100" dirty="0"/>
-              <a:t>All data is artificially generated!</a:t>
-            </a:r>
-          </a:p>
-        </p:txBody>
-      </p:sp>
       <p:sp>
         <p:nvSpPr>
           <p:cNvPr id="5" name="mins">
@@ -2222,7 +2119,7 @@
           <p:nvPr userDrawn="1"/>
         </p:nvPicPr>
         <p:blipFill>
-          <a:blip r:embed="rId11">
+          <a:blip r:embed="rId9">
             <a:clrChange>
               <a:clrFrom>
                 <a:srgbClr val="000000"/>
@@ -2236,7 +2133,7 @@
             <a:extLst>
               <a:ext uri="{BEBA8EAE-BF5A-486C-A8C5-ECC9F3942E4B}">
                 <a14:imgProps xmlns:a14="http://schemas.microsoft.com/office/drawing/2010/main">
-                  <a14:imgLayer r:embed="rId12">
+                  <a14:imgLayer r:embed="rId10">
                     <a14:imgEffect>
                       <a14:backgroundRemoval t="10000" b="90000" l="10000" r="90000">
                         <a14:foregroundMark x1="42383" y1="45117" x2="42383" y2="45117"/>
@@ -2291,7 +2188,7 @@
           <p:nvPr userDrawn="1"/>
         </p:nvPicPr>
         <p:blipFill>
-          <a:blip r:embed="rId13"/>
+          <a:blip r:embed="rId11"/>
           <a:stretch>
             <a:fillRect/>
           </a:stretch>

</xml_diff>

<commit_message>
Update PCI Clinician Report based on initial feedback
</commit_message>
<xml_diff>
--- a/pci_poster/poster_template.pptx
+++ b/pci_poster/poster_template.pptx
@@ -732,7 +732,7 @@
           <a:p>
             <a:fld id="{71C53CA5-41C7-4923-8C6F-B3E91010339F}" type="datetimeFigureOut">
               <a:rPr lang="en-AU" smtClean="0"/>
-              <a:t>14/08/2026</a:t>
+              <a:t>18/08/2026</a:t>
             </a:fld>
             <a:endParaRPr lang="en-AU"/>
           </a:p>
@@ -909,7 +909,7 @@
           <a:p>
             <a:fld id="{C000ED89-5811-46A2-AFCA-7C8C83CE9906}" type="datetimeFigureOut">
               <a:rPr lang="en-AU" smtClean="0"/>
-              <a:t>14/08/2026</a:t>
+              <a:t>18/08/2026</a:t>
             </a:fld>
             <a:endParaRPr lang="en-AU"/>
           </a:p>
@@ -1781,8 +1781,13 @@
             <a:pPr lvl="0"/>
             <a:r>
               <a:rPr lang="en-AU" dirty="0"/>
-              <a:t>X out of Y patients had Radial Access</a:t>
+              <a:t>X of Y </a:t>
             </a:r>
+            <a:r>
+              <a:rPr lang="en-GB" dirty="0"/>
+              <a:t>PCI were performed via Radial Access</a:t>
+            </a:r>
+            <a:endParaRPr lang="en-AU" dirty="0"/>
           </a:p>
         </p:txBody>
       </p:sp>
@@ -1804,8 +1809,8 @@
         </p:nvSpPr>
         <p:spPr>
           <a:xfrm>
-            <a:off x="3615721" y="8142019"/>
-            <a:ext cx="2820036" cy="641977"/>
+            <a:off x="3804989" y="8142019"/>
+            <a:ext cx="2630768" cy="641977"/>
           </a:xfrm>
           <a:prstGeom prst="rect">
             <a:avLst/>
@@ -1823,7 +1828,7 @@
             <a:pPr lvl="0"/>
             <a:r>
               <a:rPr lang="en-AU" dirty="0"/>
-              <a:t>X out of Y patients were discharged on Dual Anti-Platelet Therapy</a:t>
+              <a:t>X of Y patients were discharged on DAPT</a:t>
             </a:r>
           </a:p>
         </p:txBody>
@@ -1864,12 +1869,8 @@
           <a:p>
             <a:pPr lvl="0"/>
             <a:r>
-              <a:rPr lang="en-AU" dirty="0" err="1"/>
-              <a:t>Xm</a:t>
-            </a:r>
-            <a:r>
               <a:rPr lang="en-AU" dirty="0"/>
-              <a:t> (Median) Door to PCI time</a:t>
+              <a:t>Median Door to Device time was X min</a:t>
             </a:r>
           </a:p>
         </p:txBody>
@@ -1915,7 +1916,7 @@
             </a:r>
             <a:r>
               <a:rPr lang="en-AU" dirty="0"/>
-              <a:t> PCI performed</a:t>
+              <a:t> PCI performed.                      Y (Z%) were entered into the PCI Database.</a:t>
             </a:r>
           </a:p>
         </p:txBody>
@@ -1957,7 +1958,7 @@
             <a:pPr lvl="0"/>
             <a:r>
               <a:rPr lang="en-AU" dirty="0"/>
-              <a:t>X out of Y PCI performed for STEMI</a:t>
+              <a:t>X of Y PCI were emergencies for STEMI</a:t>
             </a:r>
           </a:p>
         </p:txBody>
@@ -1980,8 +1981,8 @@
         </p:nvSpPr>
         <p:spPr>
           <a:xfrm>
-            <a:off x="484767" y="8149544"/>
-            <a:ext cx="2587573" cy="497504"/>
+            <a:off x="345057" y="8149544"/>
+            <a:ext cx="2589127" cy="497504"/>
           </a:xfrm>
           <a:prstGeom prst="rect">
             <a:avLst/>
@@ -1998,8 +1999,12 @@
           <a:p>
             <a:pPr lvl="0"/>
             <a:r>
+              <a:rPr lang="en-GB" dirty="0"/>
+              <a:t>Evidence of referral to Cardiac Rehab was available in </a:t>
+            </a:r>
+            <a:r>
               <a:rPr lang="en-AU" dirty="0"/>
-              <a:t>X out of Y had evidence of referral to Cardiac Rehab</a:t>
+              <a:t>X out of Y patients</a:t>
             </a:r>
           </a:p>
         </p:txBody>
@@ -2023,7 +2028,7 @@
         <p:spPr>
           <a:xfrm>
             <a:off x="216695" y="1562072"/>
-            <a:ext cx="4405789" cy="344012"/>
+            <a:ext cx="4958583" cy="344012"/>
           </a:xfrm>
           <a:prstGeom prst="roundRect">
             <a:avLst/>

</xml_diff>